<commit_message>
Update migration deck for full-time timeline and add Word version
Timeline changes from 4-6 months after hours to about 3-4 weeks of
full-time build. Adds the options, considerations and pricing document
as .docx.

Co-Authored-By: Claude Sonnet 5.5 <noreply@anthropic.com>
Claude-Session: https://claude.ai/code/session_01KJtFxuEaUDPzkEMnDgLJHH
</commit_message>
<xml_diff>
--- a/quotes/2026-09-15-sanity-to-mongodb-migration/CaterFlow-MongoDB-Migration-Deck.pptx
+++ b/quotes/2026-09-15-sanity-to-mongodb-migration/CaterFlow-MongoDB-Migration-Deck.pptx
@@ -125,26 +125,26 @@
   <p:extLst>
     <p:ext uri="{521415D9-36F7-43E2-AB2F-B90AF26B5E84}">
       <p14:sectionLst xmlns:p14="http://schemas.microsoft.com/office/powerpoint/2010/main">
-        <p14:section name="Introduction" id="{74442f9b-63fb-f9af-e8a0-3e92d1de91c3}">
+        <p14:section name="Introduction" id="{4f7fc38c-167c-b595-8f3a-dea10ebb9b29}">
           <p14:sldIdLst>
             <p14:sldId id="256"/>
             <p14:sldId id="257"/>
           </p14:sldIdLst>
         </p14:section>
-        <p14:section name="Why this matters" id="{bd600f0d-58ae-e071-8309-aa5f9b86dbbb}">
+        <p14:section name="Why this matters" id="{9644c9a3-d0da-b188-a0be-5be2d82f1757}">
           <p14:sldIdLst>
             <p14:sldId id="258"/>
             <p14:sldId id="259"/>
             <p14:sldId id="260"/>
           </p14:sldIdLst>
         </p14:section>
-        <p14:section name="Why MongoDB" id="{702d8cb4-6bd0-ba5e-d15a-9a0320e788bf}">
+        <p14:section name="Why MongoDB" id="{d982c743-4217-9f95-518d-a9b6e7441304}">
           <p14:sldIdLst>
             <p14:sldId id="261"/>
             <p14:sldId id="262"/>
           </p14:sldIdLst>
         </p14:section>
-        <p14:section name="Scope and price" id="{a604d23f-4063-04fd-427d-cd99e5d6a34f}">
+        <p14:section name="Scope and price" id="{6d7a5dde-e7cd-3969-0963-189110f0f829}">
           <p14:sldIdLst>
             <p14:sldId id="263"/>
             <p14:sldId id="264"/>
@@ -153,7 +153,7 @@
             <p14:sldId id="267"/>
           </p14:sldIdLst>
         </p14:section>
-        <p14:section name="Hosting" id="{961f4e75-c2ad-bd51-179d-481b62dfa2fb}">
+        <p14:section name="Hosting" id="{a2fee346-d2d1-6dbb-5ab1-9c00f20011e8}">
           <p14:sldIdLst>
             <p14:sldId id="268"/>
             <p14:sldId id="269"/>
@@ -161,7 +161,7 @@
             <p14:sldId id="271"/>
           </p14:sldIdLst>
         </p14:section>
-        <p14:section name="Decision" id="{ff1133f2-48d7-7143-eb64-976730db0d83}">
+        <p14:section name="Decision" id="{59e0f4c3-c10a-3b9e-b477-986169eac75d}">
           <p14:sldIdLst>
             <p14:sldId id="272"/>
             <p14:sldId id="273"/>
@@ -1973,7 +1973,7 @@
           <a:p>
             <a:r>
               <a:rPr lang="en-US" dirty="0"/>
-              <a:t>The quota block is the urgent item: the migration takes months and Sanity is binding now, so the retention fix needs to be deployed in the meantime, after a backup. Also confirm ARCHIVE_DAYS_THRESHOLD in production.</a:t>
+              <a:t>The quota block is the urgent item: the migration takes weeks and Sanity is binding now, so the retention fix needs to be deployed in the meantime, after a backup. Also confirm ARCHIVE_DAYS_THRESHOLD in production.</a:t>
             </a:r>
             <a:endParaRPr lang="en-US" dirty="0"/>
           </a:p>
@@ -2237,7 +2237,7 @@
           <a:p>
             <a:r>
               <a:rPr lang="en-US" dirty="0"/>
-              <a:t>The decision in one page. Production was blocked by Sanity's document quota at about 31,059 live documents. The migration touches about 24,784 documents and is quoted as a fixed SZL 20,000 over 96 to 139 estimated hours. Hosting is not part of the quote.</a:t>
+              <a:t>The decision in one page. Production was blocked by Sanity's document quota at about 31,059 live documents. The migration touches about 24,784 documents and is quoted as a fixed SZL 20,000 over 96 to 139 estimated hours. Hosting is not part of the quote. Timeline: the work is now full-time, so about 3 to 4 weeks of build at 40 hours a week (estimate; the quote assumed 4 to 6 months after hours), plus a rollback window. The quote's fixed fee is unchanged here; whether the discounted rate still applies to full-time work is a decision for G-Solutions².</a:t>
             </a:r>
             <a:endParaRPr lang="en-US" dirty="0"/>
           </a:p>
@@ -4169,7 +4169,7 @@
                   <a:schemeClr val="tx1"/>
                 </a:solidFill>
               </a:rPr>
-              <a:t>discounted project rate for the size and length of the engagement</a:t>
+              <a:t>discounted project rate for the size of the engagement</a:t>
             </a:r>
             <a:endParaRPr lang="en-US" sz="1400" dirty="0"/>
           </a:p>
@@ -10526,7 +10526,7 @@
                   <a:schemeClr val="tx1"/>
                 </a:solidFill>
               </a:rPr>
-              <a:t>The biggest near-term risk is the gap: migration takes 4–6 months, and the quota is binding today.</a:t>
+              <a:t>The biggest near-term risk is the gap: migration takes about 3–4 weeks of full-time work, and the quota is binding today.</a:t>
             </a:r>
             <a:endParaRPr lang="en-US" sz="1600" dirty="0"/>
           </a:p>
@@ -14129,7 +14129,7 @@
                 <a:ea typeface="+mj-lt" pitchFamily="34" charset="-122"/>
                 <a:cs typeface="+mj-lt" pitchFamily="34" charset="-120"/>
               </a:rPr>
-              <a:t>4–6</a:t>
+              <a:t>3–4</a:t>
             </a:r>
             <a:endParaRPr lang="en-US" sz="4000" dirty="0"/>
           </a:p>
@@ -14165,7 +14165,7 @@
                   <a:schemeClr val="tx1"/>
                 </a:solidFill>
               </a:rPr>
-              <a:t>months at the current after-hours pace</a:t>
+              <a:t>weeks of full-time build, plus a rollback window</a:t>
             </a:r>
             <a:endParaRPr lang="en-US" sz="1400" dirty="0"/>
           </a:p>

</xml_diff>

<commit_message>
Remove Sanity record counts from deck and document
Replace specific document counts with the quote's wording (roughly
24,800+ documents to migrate) and rework the quota slide so it no
longer relies on record counts.

Co-Authored-By: Claude Sonnet 5.5 <noreply@anthropic.com>
Claude-Session: https://claude.ai/code/session_01KJtFxuEaUDPzkEMnDgLJHH
</commit_message>
<xml_diff>
--- a/quotes/2026-09-15-sanity-to-mongodb-migration/CaterFlow-MongoDB-Migration-Deck.pptx
+++ b/quotes/2026-09-15-sanity-to-mongodb-migration/CaterFlow-MongoDB-Migration-Deck.pptx
@@ -125,26 +125,26 @@
   <p:extLst>
     <p:ext uri="{521415D9-36F7-43E2-AB2F-B90AF26B5E84}">
       <p14:sectionLst xmlns:p14="http://schemas.microsoft.com/office/powerpoint/2010/main">
-        <p14:section name="Introduction" id="{4f7fc38c-167c-b595-8f3a-dea10ebb9b29}">
+        <p14:section name="Introduction" id="{0cf56c36-904e-431b-faa0-99ab10ed0639}">
           <p14:sldIdLst>
             <p14:sldId id="256"/>
             <p14:sldId id="257"/>
           </p14:sldIdLst>
         </p14:section>
-        <p14:section name="Why this matters" id="{9644c9a3-d0da-b188-a0be-5be2d82f1757}">
+        <p14:section name="Why this matters" id="{7b8f674d-ab0e-0168-3d7b-33e6de3316dc}">
           <p14:sldIdLst>
             <p14:sldId id="258"/>
             <p14:sldId id="259"/>
             <p14:sldId id="260"/>
           </p14:sldIdLst>
         </p14:section>
-        <p14:section name="Why MongoDB" id="{d982c743-4217-9f95-518d-a9b6e7441304}">
+        <p14:section name="Why MongoDB" id="{9d137070-a112-f57c-9bdf-89f3a002bff3}">
           <p14:sldIdLst>
             <p14:sldId id="261"/>
             <p14:sldId id="262"/>
           </p14:sldIdLst>
         </p14:section>
-        <p14:section name="Scope and price" id="{6d7a5dde-e7cd-3969-0963-189110f0f829}">
+        <p14:section name="Scope and price" id="{108fdaa4-e006-09e0-f85a-a27676fe881d}">
           <p14:sldIdLst>
             <p14:sldId id="263"/>
             <p14:sldId id="264"/>
@@ -153,7 +153,7 @@
             <p14:sldId id="267"/>
           </p14:sldIdLst>
         </p14:section>
-        <p14:section name="Hosting" id="{a2fee346-d2d1-6dbb-5ab1-9c00f20011e8}">
+        <p14:section name="Hosting" id="{78d4490f-a4ef-94d2-c5e6-e8b3f76af36a}">
           <p14:sldIdLst>
             <p14:sldId id="268"/>
             <p14:sldId id="269"/>
@@ -161,7 +161,7 @@
             <p14:sldId id="271"/>
           </p14:sldIdLst>
         </p14:section>
-        <p14:section name="Decision" id="{59e0f4c3-c10a-3b9e-b477-986169eac75d}">
+        <p14:section name="Decision" id="{ea3266d6-2949-af1f-9d8a-e1d66bd02feb}">
           <p14:sldIdLst>
             <p14:sldId id="272"/>
             <p14:sldId id="273"/>
@@ -178,414 +178,6 @@
 </file>
 
 <file path=ppt/charts/chart1.xml><?xml version="1.0" encoding="utf-8"?>
-<c:chartSpace xmlns:c="http://schemas.openxmlformats.org/drawingml/2006/chart" xmlns:a="http://schemas.openxmlformats.org/drawingml/2006/main" xmlns:r="http://schemas.openxmlformats.org/officeDocument/2006/relationships">
-  <c:date1904 val="0"/>
-  <c:roundedCorners val="1"/>
-  <c:chart>
-    <c:title>
-      <c:tx>
-        <c:rich>
-          <a:bodyPr/>
-          <a:lstStyle/>
-          <a:p>
-            <a:pPr>
-              <a:defRPr sz="1400" b="0" i="0" u="none" strike="noStrike">
-                <a:solidFill>
-                  <a:srgbClr val="16241F"/>
-                </a:solidFill>
-                <a:latin typeface="+mn-lt"/>
-              </a:defRPr>
-            </a:pPr>
-            <a:r>
-              <a:rPr sz="1400" b="0" i="0" u="none" strike="noStrike">
-                <a:solidFill>
-                  <a:srgbClr val="16241F"/>
-                </a:solidFill>
-                <a:latin typeface="+mn-lt"/>
-              </a:rPr>
-              <a:t>Documents deletable under the 60-day policy</a:t>
-            </a:r>
-          </a:p>
-        </c:rich>
-      </c:tx>
-      <c:layout/>
-      <c:overlay val="0"/>
-    </c:title>
-    <c:autoTitleDeleted val="0"/>
-    <c:plotArea>
-      <c:layout/>
-      <c:barChart>
-        <c:barDir val="col"/>
-        <c:grouping val="clustered"/>
-        <c:varyColors val="0"/>
-        <c:ser>
-          <c:idx val="0"/>
-          <c:order val="0"/>
-          <c:tx>
-            <c:strRef>
-              <c:f>Sheet1!$B$1</c:f>
-              <c:strCache>
-                <c:ptCount val="1"/>
-                <c:pt idx="0">
-                  <c:v>Deletable before the fix</c:v>
-                </c:pt>
-              </c:strCache>
-            </c:strRef>
-          </c:tx>
-          <c:spPr>
-            <a:solidFill>
-              <a:srgbClr val="6B7F78"/>
-            </a:solidFill>
-            <a:effectLst/>
-          </c:spPr>
-          <c:invertIfNegative val="0"/>
-          <c:dLbls>
-            <c:numFmt formatCode="#,##0" sourceLinked="0"/>
-            <c:txPr>
-              <a:bodyPr/>
-              <a:lstStyle/>
-              <a:p>
-                <a:pPr>
-                  <a:defRPr b="0" i="0" strike="noStrike" sz="1100" u="none">
-                    <a:solidFill>
-                      <a:srgbClr val="16241F"/>
-                    </a:solidFill>
-                    <a:latin typeface="+mn-lt"/>
-                  </a:defRPr>
-                </a:pPr>
-              </a:p>
-            </c:txPr>
-            <c:showLegendKey val="0"/>
-            <c:showVal val="1"/>
-            <c:showCatName val="0"/>
-            <c:showSerName val="0"/>
-            <c:showPercent val="0"/>
-            <c:showBubbleSize val="0"/>
-            <c:showLeaderLines val="0"/>
-          </c:dLbls>
-          <c:cat>
-            <c:multiLvlStrRef>
-              <c:f>Sheet1!$A$2:$A$7</c:f>
-              <c:multiLvlStrCache>
-                <c:ptCount val="6"/>
-                <c:lvl>
-                  <c:pt idx="0">
-                    <c:v>Dispatch logs</c:v>
-                  </c:pt>
-                  <c:pt idx="1">
-                    <c:v>Purchase orders</c:v>
-                  </c:pt>
-                  <c:pt idx="2">
-                    <c:v>Goods receipts</c:v>
-                  </c:pt>
-                  <c:pt idx="3">
-                    <c:v>Inventory counts</c:v>
-                  </c:pt>
-                  <c:pt idx="4">
-                    <c:v>File attachments</c:v>
-                  </c:pt>
-                  <c:pt idx="5">
-                    <c:v>Stock adjustments</c:v>
-                  </c:pt>
-                </c:lvl>
-              </c:multiLvlStrCache>
-            </c:multiLvlStrRef>
-          </c:cat>
-          <c:val>
-            <c:numRef>
-              <c:f>Sheet1!$B$2:$B$7</c:f>
-              <c:numCache>
-                <c:formatCode>General</c:formatCode>
-                <c:ptCount val="6"/>
-                <c:pt idx="0">
-                  <c:v>1</c:v>
-                </c:pt>
-                <c:pt idx="1">
-                  <c:v>576</c:v>
-                </c:pt>
-                <c:pt idx="2">
-                  <c:v>0</c:v>
-                </c:pt>
-                <c:pt idx="3">
-                  <c:v>1</c:v>
-                </c:pt>
-                <c:pt idx="4">
-                  <c:v>0</c:v>
-                </c:pt>
-                <c:pt idx="5">
-                  <c:v>8</c:v>
-                </c:pt>
-              </c:numCache>
-            </c:numRef>
-          </c:val>
-        </c:ser>
-        <c:ser>
-          <c:idx val="1"/>
-          <c:order val="1"/>
-          <c:tx>
-            <c:strRef>
-              <c:f>Sheet1!$C$1</c:f>
-              <c:strCache>
-                <c:ptCount val="1"/>
-                <c:pt idx="0">
-                  <c:v>Deletable after the fix</c:v>
-                </c:pt>
-              </c:strCache>
-            </c:strRef>
-          </c:tx>
-          <c:spPr>
-            <a:solidFill>
-              <a:srgbClr val="1F8A5B"/>
-            </a:solidFill>
-            <a:effectLst/>
-          </c:spPr>
-          <c:invertIfNegative val="0"/>
-          <c:dLbls>
-            <c:numFmt formatCode="#,##0" sourceLinked="0"/>
-            <c:txPr>
-              <a:bodyPr/>
-              <a:lstStyle/>
-              <a:p>
-                <a:pPr>
-                  <a:defRPr b="0" i="0" strike="noStrike" sz="1100" u="none">
-                    <a:solidFill>
-                      <a:srgbClr val="16241F"/>
-                    </a:solidFill>
-                    <a:latin typeface="+mn-lt"/>
-                  </a:defRPr>
-                </a:pPr>
-              </a:p>
-            </c:txPr>
-            <c:showLegendKey val="0"/>
-            <c:showVal val="1"/>
-            <c:showCatName val="0"/>
-            <c:showSerName val="0"/>
-            <c:showPercent val="0"/>
-            <c:showBubbleSize val="0"/>
-            <c:showLeaderLines val="0"/>
-          </c:dLbls>
-          <c:cat>
-            <c:multiLvlStrRef>
-              <c:f>Sheet1!$A$2:$A$7</c:f>
-              <c:multiLvlStrCache>
-                <c:ptCount val="6"/>
-                <c:lvl>
-                  <c:pt idx="0">
-                    <c:v>Dispatch logs</c:v>
-                  </c:pt>
-                  <c:pt idx="1">
-                    <c:v>Purchase orders</c:v>
-                  </c:pt>
-                  <c:pt idx="2">
-                    <c:v>Goods receipts</c:v>
-                  </c:pt>
-                  <c:pt idx="3">
-                    <c:v>Inventory counts</c:v>
-                  </c:pt>
-                  <c:pt idx="4">
-                    <c:v>File attachments</c:v>
-                  </c:pt>
-                  <c:pt idx="5">
-                    <c:v>Stock adjustments</c:v>
-                  </c:pt>
-                </c:lvl>
-              </c:multiLvlStrCache>
-            </c:multiLvlStrRef>
-          </c:cat>
-          <c:val>
-            <c:numRef>
-              <c:f>Sheet1!$C$2:$C$7</c:f>
-              <c:numCache>
-                <c:formatCode>General</c:formatCode>
-                <c:ptCount val="6"/>
-                <c:pt idx="0">
-                  <c:v>4307</c:v>
-                </c:pt>
-                <c:pt idx="1">
-                  <c:v>2241</c:v>
-                </c:pt>
-                <c:pt idx="2">
-                  <c:v>2219</c:v>
-                </c:pt>
-                <c:pt idx="3">
-                  <c:v>167</c:v>
-                </c:pt>
-                <c:pt idx="4">
-                  <c:v>3009</c:v>
-                </c:pt>
-                <c:pt idx="5">
-                  <c:v>0</c:v>
-                </c:pt>
-              </c:numCache>
-            </c:numRef>
-          </c:val>
-        </c:ser>
-        <c:dLbls>
-          <c:numFmt formatCode="#,##0" sourceLinked="0"/>
-          <c:txPr>
-            <a:bodyPr/>
-            <a:lstStyle/>
-            <a:p>
-              <a:pPr>
-                <a:defRPr b="0" i="0" strike="noStrike" sz="1100" u="none">
-                  <a:solidFill>
-                    <a:srgbClr val="16241F"/>
-                  </a:solidFill>
-                  <a:latin typeface="+mn-lt"/>
-                </a:defRPr>
-              </a:pPr>
-            </a:p>
-          </c:txPr>
-          <c:showLegendKey val="0"/>
-          <c:showVal val="1"/>
-          <c:showCatName val="0"/>
-          <c:showSerName val="0"/>
-          <c:showPercent val="0"/>
-          <c:showBubbleSize val="0"/>
-          <c:showLeaderLines val="0"/>
-        </c:dLbls>
-        <c:gapWidth val="150"/>
-        <c:overlap val="0"/>
-        <c:axId val="2094734554"/>
-        <c:axId val="2094734552"/>
-        <c:axId val="2094734556"/>
-      </c:barChart>
-      <c:catAx>
-        <c:axId val="2094734554"/>
-        <c:scaling>
-          <c:orientation val="minMax"/>
-        </c:scaling>
-        <c:delete val="0"/>
-        <c:axPos val="b"/>
-        <c:numFmt formatCode="General" sourceLinked="1"/>
-        <c:majorTickMark val="out"/>
-        <c:minorTickMark val="none"/>
-        <c:tickLblPos val="low"/>
-        <c:spPr>
-          <a:ln w="12700" cap="flat">
-            <a:solidFill>
-              <a:srgbClr val="888888"/>
-            </a:solidFill>
-            <a:prstDash val="solid"/>
-            <a:round/>
-          </a:ln>
-        </c:spPr>
-        <c:txPr>
-          <a:bodyPr/>
-          <a:lstStyle/>
-          <a:p>
-            <a:pPr>
-              <a:defRPr sz="1200" b="0" i="0" u="none" strike="noStrike">
-                <a:solidFill>
-                  <a:srgbClr val="16241F"/>
-                </a:solidFill>
-                <a:latin typeface="+mn-lt"/>
-              </a:defRPr>
-            </a:pPr>
-            <a:endParaRPr lang="en-US"/>
-          </a:p>
-        </c:txPr>
-        <c:crossAx val="2094734552"/>
-        <c:crosses val="autoZero"/>
-        <c:auto val="1"/>
-        <c:lblAlgn val="ctr"/>
-        <c:noMultiLvlLbl val="1"/>
-      </c:catAx>
-      <c:valAx>
-        <c:axId val="2094734552"/>
-        <c:scaling>
-          <c:orientation val="minMax"/>
-        </c:scaling>
-        <c:delete val="0"/>
-        <c:axPos val="l"/>
-        <c:majorGridlines>
-          <c:spPr>
-            <a:ln w="6350" cap="flat">
-              <a:solidFill>
-                <a:srgbClr val="D5E1DB"/>
-              </a:solidFill>
-              <a:prstDash val="solid"/>
-              <a:round/>
-            </a:ln>
-          </c:spPr>
-        </c:majorGridlines>
-        <c:numFmt formatCode="#,##0" sourceLinked="0"/>
-        <c:majorTickMark val="out"/>
-        <c:minorTickMark val="none"/>
-        <c:tickLblPos val="nextTo"/>
-        <c:spPr>
-          <a:ln w="12700" cap="flat">
-            <a:solidFill>
-              <a:srgbClr val="888888"/>
-            </a:solidFill>
-            <a:prstDash val="solid"/>
-            <a:round/>
-          </a:ln>
-        </c:spPr>
-        <c:txPr>
-          <a:bodyPr/>
-          <a:lstStyle/>
-          <a:p>
-            <a:pPr>
-              <a:defRPr sz="1100" b="0" i="0" u="none" strike="noStrike">
-                <a:solidFill>
-                  <a:srgbClr val="6B7F78"/>
-                </a:solidFill>
-                <a:latin typeface="+mn-lt"/>
-              </a:defRPr>
-            </a:pPr>
-            <a:endParaRPr lang="en-US"/>
-          </a:p>
-        </c:txPr>
-        <c:crossAx val="2094734554"/>
-        <c:crosses val="autoZero"/>
-        <c:crossBetween val="between"/>
-      </c:valAx>
-      <c:spPr>
-        <a:noFill/>
-        <a:ln>
-          <a:noFill/>
-        </a:ln>
-        <a:effectLst/>
-      </c:spPr>
-    </c:plotArea>
-    <c:legend>
-      <c:legendPos val="b"/>
-      <c:overlay val="0"/>
-      <c:txPr>
-        <a:bodyPr/>
-        <a:lstStyle/>
-        <a:p>
-          <a:pPr>
-            <a:defRPr sz="1200">
-              <a:solidFill>
-                <a:srgbClr val="16241F"/>
-              </a:solidFill>
-              <a:latin typeface="+mn-lt"/>
-              <a:cs typeface="+mn-lt"/>
-            </a:defRPr>
-          </a:pPr>
-          <a:endParaRPr lang="en-US"/>
-        </a:p>
-      </c:txPr>
-    </c:legend>
-    <c:plotVisOnly val="1"/>
-    <c:dispBlanksAs val="span"/>
-  </c:chart>
-  <c:spPr>
-    <a:noFill/>
-    <a:ln>
-      <a:noFill/>
-    </a:ln>
-    <a:effectLst/>
-  </c:spPr>
-  <c:externalData r:id="rId1">
-    <c:autoUpdate val="0"/>
-  </c:externalData>
-</c:chartSpace>
-</file>
-
-<file path=ppt/charts/chart2.xml><?xml version="1.0" encoding="utf-8"?>
 <c:chartSpace xmlns:c="http://schemas.openxmlformats.org/drawingml/2006/chart" xmlns:a="http://schemas.openxmlformats.org/drawingml/2006/main" xmlns:r="http://schemas.openxmlformats.org/officeDocument/2006/relationships">
   <c:date1904 val="0"/>
   <c:roundedCorners val="1"/>
@@ -2237,7 +1829,7 @@
           <a:p>
             <a:r>
               <a:rPr lang="en-US" dirty="0"/>
-              <a:t>The decision in one page. Production was blocked by Sanity's document quota at about 31,059 live documents. The migration touches about 24,784 documents and is quoted as a fixed SZL 20,000 over 96 to 139 estimated hours. Hosting is not part of the quote. Timeline: the work is now full-time, so about 3 to 4 weeks of build at 40 hours a week (estimate; the quote assumed 4 to 6 months after hours), plus a rollback window. The quote's fixed fee is unchanged here; whether the discounted rate still applies to full-time work is a decision for G-Solutions².</a:t>
+              <a:t>The decision in one page. Production was blocked by Sanity's document quota. The migration touches roughly 24,800+ documents, as the quote states, and is quoted as a fixed SZL 20,000 over 96 to 139 estimated hours. Hosting is not part of the quote. Timeline: the work is now full-time, so about 3 to 4 weeks of build at 40 hours a week (estimate; the quote assumed 4 to 6 months after hours), plus a rollback window. The quote's fixed fee is unchanged here; whether the discounted rate still applies to full-time work is a decision for G-Solutions².</a:t>
             </a:r>
             <a:endParaRPr lang="en-US" dirty="0"/>
           </a:p>
@@ -2325,7 +1917,7 @@
           <a:p>
             <a:r>
               <a:rPr lang="en-US" dirty="0"/>
-              <a:t>Source: retention findings report CATERFLOW-RETENTION-2026-09-22-R2. Before the fix only 586 documents passed the deletion gate; after it, 11,943. The fix is in code and tested but not deployed. The report itself says the fix is necessary but not sufficient.</a:t>
+              <a:t>Source: the retention findings report of 22 September 2026. The deletion step compared the archive copy date against the 60-day cutoff instead of each document's own business date. The fix is in code and tested but not deployed, and the report itself says it is necessary but not sufficient. I have deliberately left out the document counts from that report.</a:t>
             </a:r>
             <a:endParaRPr lang="en-US" dirty="0"/>
           </a:p>
@@ -2765,7 +2357,7 @@
           <a:p>
             <a:r>
               <a:rPr lang="en-US" dirty="0"/>
-              <a:t>Numbers come from the codebase as read in September 2026: 64 files import Sanity, 54 route files, about 194 GROQ blocks and 211 fetch calls, 24 schema types and about 24,784 documents in the latest production export. No evidence the client uses Studio directly, but that needs confirming with them.</a:t>
+              <a:t>Numbers come from the codebase as read in September 2026: 64 files import Sanity, 54 route files, about 194 GROQ blocks and 211 fetch calls, 24 schema types and roughly 24,800+ documents to migrate, as the quote states. No evidence the client uses Studio directly, but that needs confirming with them.</a:t>
             </a:r>
             <a:endParaRPr lang="en-US" dirty="0"/>
           </a:p>
@@ -10820,7 +10412,7 @@
                             <a:schemeClr val="tx1"/>
                           </a:solidFill>
                         </a:rPr>
-                        <a:t>Blocked at about 31,059 live documents; the deletion fix is not deployed</a:t>
+                        <a:t>Production was blocked by the quota; the deletion fix is not deployed</a:t>
                       </a:r>
                       <a:endParaRPr lang="en-US" sz="1300" dirty="0"/>
                     </a:p>
@@ -11005,7 +10597,7 @@
                             <a:schemeClr val="tx1"/>
                           </a:solidFill>
                         </a:rPr>
-                        <a:t>The assumed 50,000-document tier was contradicted</a:t>
+                        <a:t>The assumed document-limit tier was contradicted</a:t>
                       </a:r>
                       <a:endParaRPr lang="en-US" sz="1300" dirty="0"/>
                     </a:p>
@@ -13832,13 +13424,13 @@
             <a:r>
               <a:rPr lang="en-US" sz="4000" b="1" dirty="0">
                 <a:solidFill>
-                  <a:schemeClr val="accent1"/>
+                  <a:schemeClr val="accent3"/>
                 </a:solidFill>
                 <a:latin typeface="+mj-lt" pitchFamily="34" charset="0"/>
                 <a:ea typeface="+mj-lt" pitchFamily="34" charset="-122"/>
                 <a:cs typeface="+mj-lt" pitchFamily="34" charset="-120"/>
               </a:rPr>
-              <a:t>31,059</a:t>
+              <a:t>Blocked</a:t>
             </a:r>
             <a:endParaRPr lang="en-US" sz="4000" dirty="0"/>
           </a:p>
@@ -13874,7 +13466,7 @@
                   <a:schemeClr val="tx1"/>
                 </a:solidFill>
               </a:rPr>
-              <a:t>live Sanity documents when production was blocked</a:t>
+              <a:t>production has already hit Sanity's document quota</a:t>
             </a:r>
             <a:endParaRPr lang="en-US" sz="1400" dirty="0"/>
           </a:p>
@@ -13935,7 +13527,7 @@
                 <a:ea typeface="+mj-lt" pitchFamily="34" charset="-122"/>
                 <a:cs typeface="+mj-lt" pitchFamily="34" charset="-120"/>
               </a:rPr>
-              <a:t>24,784</a:t>
+              <a:t>24,800+</a:t>
             </a:r>
             <a:endParaRPr lang="en-US" sz="4000" dirty="0"/>
           </a:p>
@@ -14657,135 +14249,22 @@
                   <a:schemeClr val="tx1"/>
                 </a:solidFill>
               </a:rPr>
-              <a:t>The deletion step checked the archive date instead of the business date, so the 60-day cleanup barely ran.</a:t>
+              <a:t>The cleanup checked the date a document was copied to the archive, not its own business date, so most old documents were never removed.</a:t>
             </a:r>
             <a:endParaRPr lang="en-US" sz="1600" dirty="0"/>
           </a:p>
         </p:txBody>
       </p:sp>
-      <p:graphicFrame>
-        <p:nvGraphicFramePr>
-          <p:cNvPr id="4" name="Chart 0" descr=""/>
-          <p:cNvGraphicFramePr/>
-          <p:nvPr/>
-        </p:nvGraphicFramePr>
-        <p:xfrm>
-          <a:off x="548640" y="1920240"/>
-          <a:ext cx="7589520" cy="4343400"/>
-        </p:xfrm>
-        <a:graphic xmlns:a="http://schemas.openxmlformats.org/drawingml/2006/main">
-          <a:graphicData uri="http://schemas.openxmlformats.org/drawingml/2006/chart">
-            <c:chart xmlns:c="http://schemas.openxmlformats.org/drawingml/2006/chart" r:id="rId1"/>
-          </a:graphicData>
-        </a:graphic>
-      </p:graphicFrame>
-      <p:sp>
-        <p:nvSpPr>
-          <p:cNvPr id="5" name="Total card"/>
+      <p:sp>
+        <p:nvSpPr>
+          <p:cNvPr id="4" name="Clock card 1"/>
           <p:cNvSpPr/>
           <p:nvPr/>
         </p:nvSpPr>
         <p:spPr>
           <a:xfrm>
-            <a:off x="8412480" y="1920240"/>
-            <a:ext cx="3227832" cy="2103120"/>
-          </a:xfrm>
-          <a:prstGeom prst="roundRect">
-            <a:avLst>
-              <a:gd name="adj" fmla="val 4348"/>
-            </a:avLst>
-          </a:prstGeom>
-          <a:solidFill>
-            <a:schemeClr val="bg2"/>
-          </a:solidFill>
-          <a:ln/>
-        </p:spPr>
-      </p:sp>
-      <p:sp>
-        <p:nvSpPr>
-          <p:cNvPr id="6" name="Total value"/>
-          <p:cNvSpPr txBox="1"/>
-          <p:nvPr/>
-        </p:nvSpPr>
-        <p:spPr>
-          <a:xfrm>
-            <a:off x="8641080" y="2103120"/>
-            <a:ext cx="2834640" cy="731520"/>
-          </a:xfrm>
-          <a:prstGeom prst="rect">
-            <a:avLst/>
-          </a:prstGeom>
-          <a:noFill/>
-          <a:ln/>
-        </p:spPr>
-        <p:txBody>
-          <a:bodyPr wrap="square" lIns="0" tIns="0" rIns="0" bIns="0" rtlCol="0" anchor="ctr"/>
-          <a:lstStyle/>
-          <a:p>
-            <a:pPr indent="0" marL="0">
-              <a:buNone/>
-            </a:pPr>
-            <a:r>
-              <a:rPr lang="en-US" sz="2600" b="1" dirty="0">
-                <a:solidFill>
-                  <a:schemeClr val="accent1"/>
-                </a:solidFill>
-                <a:latin typeface="+mj-lt" pitchFamily="34" charset="0"/>
-                <a:ea typeface="+mj-lt" pitchFamily="34" charset="-122"/>
-                <a:cs typeface="+mj-lt" pitchFamily="34" charset="-120"/>
-              </a:rPr>
-              <a:t>586 → 11,943</a:t>
-            </a:r>
-            <a:endParaRPr lang="en-US" sz="2600" dirty="0"/>
-          </a:p>
-        </p:txBody>
-      </p:sp>
-      <p:sp>
-        <p:nvSpPr>
-          <p:cNvPr id="7" name="Total label"/>
-          <p:cNvSpPr txBox="1"/>
-          <p:nvPr/>
-        </p:nvSpPr>
-        <p:spPr>
-          <a:xfrm>
-            <a:off x="8641080" y="2926080"/>
-            <a:ext cx="2834640" cy="914400"/>
-          </a:xfrm>
-          <a:prstGeom prst="rect">
-            <a:avLst/>
-          </a:prstGeom>
-          <a:noFill/>
-          <a:ln/>
-        </p:spPr>
-        <p:txBody>
-          <a:bodyPr wrap="square" lIns="0" tIns="0" rIns="0" bIns="0" rtlCol="0" anchor="t"/>
-          <a:lstStyle/>
-          <a:p>
-            <a:pPr indent="0" marL="0">
-              <a:buNone/>
-            </a:pPr>
-            <a:r>
-              <a:rPr lang="en-US" sz="1400" dirty="0">
-                <a:solidFill>
-                  <a:schemeClr val="tx1"/>
-                </a:solidFill>
-              </a:rPr>
-              <a:t>documents deletable, before and after the fix</a:t>
-            </a:r>
-            <a:endParaRPr lang="en-US" sz="1400" dirty="0"/>
-          </a:p>
-        </p:txBody>
-      </p:sp>
-      <p:sp>
-        <p:nvSpPr>
-          <p:cNvPr id="8" name="Status card"/>
-          <p:cNvSpPr/>
-          <p:nvPr/>
-        </p:nvSpPr>
-        <p:spPr>
-          <a:xfrm>
-            <a:off x="8412480" y="4206240"/>
-            <a:ext cx="3227832" cy="2057400"/>
+            <a:off x="548640" y="1965960"/>
+            <a:ext cx="7589520" cy="2057400"/>
           </a:xfrm>
           <a:prstGeom prst="roundRect">
             <a:avLst>
@@ -14800,7 +14279,493 @@
       </p:sp>
       <p:sp>
         <p:nvSpPr>
-          <p:cNvPr id="9" name="Status heading"/>
+          <p:cNvPr id="5" name="Clock 1 circle"/>
+          <p:cNvSpPr/>
+          <p:nvPr/>
+        </p:nvSpPr>
+        <p:spPr>
+          <a:xfrm>
+            <a:off x="822960" y="2240280"/>
+            <a:ext cx="640080" cy="640080"/>
+          </a:xfrm>
+          <a:prstGeom prst="ellipse">
+            <a:avLst/>
+          </a:prstGeom>
+          <a:solidFill>
+            <a:schemeClr val="accent3"/>
+          </a:solidFill>
+          <a:ln/>
+        </p:spPr>
+      </p:sp>
+      <p:pic>
+        <p:nvPicPr>
+          <p:cNvPr id="6" name="Clock 1 icon" descr="Clock 1">    </p:cNvPr>
+          <p:cNvPicPr>
+            <a:picLocks noChangeAspect="1"/>
+          </p:cNvPicPr>
+          <p:nvPr/>
+        </p:nvPicPr>
+        <p:blipFill>
+          <a:blip r:embed="rId1"/>
+          <a:stretch>
+            <a:fillRect/>
+          </a:stretch>
+        </p:blipFill>
+        <p:spPr>
+          <a:xfrm>
+            <a:off x="982980" y="2400300"/>
+            <a:ext cx="320040" cy="320040"/>
+          </a:xfrm>
+          <a:prstGeom prst="rect">
+            <a:avLst/>
+          </a:prstGeom>
+        </p:spPr>
+      </p:pic>
+      <p:sp>
+        <p:nvSpPr>
+          <p:cNvPr id="7" name="Clock 1 heading"/>
+          <p:cNvSpPr txBox="1"/>
+          <p:nvPr/>
+        </p:nvSpPr>
+        <p:spPr>
+          <a:xfrm>
+            <a:off x="1737360" y="2240280"/>
+            <a:ext cx="4206240" cy="365760"/>
+          </a:xfrm>
+          <a:prstGeom prst="rect">
+            <a:avLst/>
+          </a:prstGeom>
+          <a:noFill/>
+          <a:ln/>
+        </p:spPr>
+        <p:txBody>
+          <a:bodyPr wrap="square" lIns="0" tIns="0" rIns="0" bIns="0" rtlCol="0" anchor="t"/>
+          <a:lstStyle/>
+          <a:p>
+            <a:pPr indent="0" marL="0">
+              <a:buNone/>
+            </a:pPr>
+            <a:r>
+              <a:rPr lang="en-US" sz="2000" b="1" dirty="0">
+                <a:solidFill>
+                  <a:schemeClr val="tx1"/>
+                </a:solidFill>
+              </a:rPr>
+              <a:t>What the cleanup checked</a:t>
+            </a:r>
+            <a:endParaRPr lang="en-US" sz="2000" dirty="0"/>
+          </a:p>
+        </p:txBody>
+      </p:sp>
+      <p:sp>
+        <p:nvSpPr>
+          <p:cNvPr id="8" name="Clock 1 tag"/>
+          <p:cNvSpPr/>
+          <p:nvPr/>
+        </p:nvSpPr>
+        <p:spPr>
+          <a:xfrm>
+            <a:off x="6583680" y="2267712"/>
+            <a:ext cx="1325880" cy="329184"/>
+          </a:xfrm>
+          <a:prstGeom prst="roundRect">
+            <a:avLst>
+              <a:gd name="adj" fmla="val 50000"/>
+            </a:avLst>
+          </a:prstGeom>
+          <a:solidFill>
+            <a:schemeClr val="accent3"/>
+          </a:solidFill>
+          <a:ln/>
+        </p:spPr>
+      </p:sp>
+      <p:sp>
+        <p:nvSpPr>
+          <p:cNvPr id="9" name="Clock 1 tag text"/>
+          <p:cNvSpPr txBox="1"/>
+          <p:nvPr/>
+        </p:nvSpPr>
+        <p:spPr>
+          <a:xfrm>
+            <a:off x="6583680" y="2267712"/>
+            <a:ext cx="1325880" cy="329184"/>
+          </a:xfrm>
+          <a:prstGeom prst="rect">
+            <a:avLst/>
+          </a:prstGeom>
+          <a:noFill/>
+          <a:ln/>
+        </p:spPr>
+        <p:txBody>
+          <a:bodyPr wrap="square" lIns="0" tIns="0" rIns="0" bIns="0" rtlCol="0" anchor="ctr"/>
+          <a:lstStyle/>
+          <a:p>
+            <a:pPr algn="ctr" indent="0" marL="0">
+              <a:buNone/>
+            </a:pPr>
+            <a:r>
+              <a:rPr lang="en-US" sz="1200" b="1" dirty="0">
+                <a:solidFill>
+                  <a:schemeClr val="bg1"/>
+                </a:solidFill>
+              </a:rPr>
+              <a:t>Wrong clock</a:t>
+            </a:r>
+            <a:endParaRPr lang="en-US" sz="1200" dirty="0"/>
+          </a:p>
+        </p:txBody>
+      </p:sp>
+      <p:sp>
+        <p:nvSpPr>
+          <p:cNvPr id="10" name="Clock 1 text"/>
+          <p:cNvSpPr txBox="1"/>
+          <p:nvPr/>
+        </p:nvSpPr>
+        <p:spPr>
+          <a:xfrm>
+            <a:off x="1737360" y="2834640"/>
+            <a:ext cx="6172200" cy="1051560"/>
+          </a:xfrm>
+          <a:prstGeom prst="rect">
+            <a:avLst/>
+          </a:prstGeom>
+          <a:noFill/>
+          <a:ln/>
+        </p:spPr>
+        <p:txBody>
+          <a:bodyPr wrap="square" lIns="0" tIns="0" rIns="0" bIns="0" rtlCol="0" anchor="t"/>
+          <a:lstStyle/>
+          <a:p>
+            <a:pPr indent="0" marL="0">
+              <a:buNone/>
+            </a:pPr>
+            <a:r>
+              <a:rPr lang="en-US" sz="1500" dirty="0">
+                <a:solidFill>
+                  <a:schemeClr val="tx1"/>
+                </a:solidFill>
+              </a:rPr>
+              <a:t>The archive copy date. After the September archive-database migration most documents had a recent copy date, so they looked too new to delete.</a:t>
+            </a:r>
+            <a:endParaRPr lang="en-US" sz="1500" dirty="0"/>
+          </a:p>
+        </p:txBody>
+      </p:sp>
+      <p:sp>
+        <p:nvSpPr>
+          <p:cNvPr id="11" name="Clock card 2"/>
+          <p:cNvSpPr/>
+          <p:nvPr/>
+        </p:nvSpPr>
+        <p:spPr>
+          <a:xfrm>
+            <a:off x="548640" y="4206240"/>
+            <a:ext cx="7589520" cy="2057400"/>
+          </a:xfrm>
+          <a:prstGeom prst="roundRect">
+            <a:avLst>
+              <a:gd name="adj" fmla="val 4444"/>
+            </a:avLst>
+          </a:prstGeom>
+          <a:solidFill>
+            <a:schemeClr val="bg2"/>
+          </a:solidFill>
+          <a:ln/>
+        </p:spPr>
+      </p:sp>
+      <p:sp>
+        <p:nvSpPr>
+          <p:cNvPr id="12" name="Clock 2 circle"/>
+          <p:cNvSpPr/>
+          <p:nvPr/>
+        </p:nvSpPr>
+        <p:spPr>
+          <a:xfrm>
+            <a:off x="822960" y="4480560"/>
+            <a:ext cx="640080" cy="640080"/>
+          </a:xfrm>
+          <a:prstGeom prst="ellipse">
+            <a:avLst/>
+          </a:prstGeom>
+          <a:solidFill>
+            <a:schemeClr val="accent1"/>
+          </a:solidFill>
+          <a:ln/>
+        </p:spPr>
+      </p:sp>
+      <p:pic>
+        <p:nvPicPr>
+          <p:cNvPr id="13" name="Clock 2 icon" descr="Clock 2">    </p:cNvPr>
+          <p:cNvPicPr>
+            <a:picLocks noChangeAspect="1"/>
+          </p:cNvPicPr>
+          <p:nvPr/>
+        </p:nvPicPr>
+        <p:blipFill>
+          <a:blip r:embed="rId2"/>
+          <a:stretch>
+            <a:fillRect/>
+          </a:stretch>
+        </p:blipFill>
+        <p:spPr>
+          <a:xfrm>
+            <a:off x="982980" y="4640580"/>
+            <a:ext cx="320040" cy="320040"/>
+          </a:xfrm>
+          <a:prstGeom prst="rect">
+            <a:avLst/>
+          </a:prstGeom>
+        </p:spPr>
+      </p:pic>
+      <p:sp>
+        <p:nvSpPr>
+          <p:cNvPr id="14" name="Clock 2 heading"/>
+          <p:cNvSpPr txBox="1"/>
+          <p:nvPr/>
+        </p:nvSpPr>
+        <p:spPr>
+          <a:xfrm>
+            <a:off x="1737360" y="4480560"/>
+            <a:ext cx="4206240" cy="365760"/>
+          </a:xfrm>
+          <a:prstGeom prst="rect">
+            <a:avLst/>
+          </a:prstGeom>
+          <a:noFill/>
+          <a:ln/>
+        </p:spPr>
+        <p:txBody>
+          <a:bodyPr wrap="square" lIns="0" tIns="0" rIns="0" bIns="0" rtlCol="0" anchor="t"/>
+          <a:lstStyle/>
+          <a:p>
+            <a:pPr indent="0" marL="0">
+              <a:buNone/>
+            </a:pPr>
+            <a:r>
+              <a:rPr lang="en-US" sz="2000" b="1" dirty="0">
+                <a:solidFill>
+                  <a:schemeClr val="tx1"/>
+                </a:solidFill>
+              </a:rPr>
+              <a:t>What it should check</a:t>
+            </a:r>
+            <a:endParaRPr lang="en-US" sz="2000" dirty="0"/>
+          </a:p>
+        </p:txBody>
+      </p:sp>
+      <p:sp>
+        <p:nvSpPr>
+          <p:cNvPr id="15" name="Clock 2 tag"/>
+          <p:cNvSpPr/>
+          <p:nvPr/>
+        </p:nvSpPr>
+        <p:spPr>
+          <a:xfrm>
+            <a:off x="6583680" y="4507992"/>
+            <a:ext cx="1325880" cy="329184"/>
+          </a:xfrm>
+          <a:prstGeom prst="roundRect">
+            <a:avLst>
+              <a:gd name="adj" fmla="val 50000"/>
+            </a:avLst>
+          </a:prstGeom>
+          <a:solidFill>
+            <a:schemeClr val="accent1"/>
+          </a:solidFill>
+          <a:ln/>
+        </p:spPr>
+      </p:sp>
+      <p:sp>
+        <p:nvSpPr>
+          <p:cNvPr id="16" name="Clock 2 tag text"/>
+          <p:cNvSpPr txBox="1"/>
+          <p:nvPr/>
+        </p:nvSpPr>
+        <p:spPr>
+          <a:xfrm>
+            <a:off x="6583680" y="4507992"/>
+            <a:ext cx="1325880" cy="329184"/>
+          </a:xfrm>
+          <a:prstGeom prst="rect">
+            <a:avLst/>
+          </a:prstGeom>
+          <a:noFill/>
+          <a:ln/>
+        </p:spPr>
+        <p:txBody>
+          <a:bodyPr wrap="square" lIns="0" tIns="0" rIns="0" bIns="0" rtlCol="0" anchor="ctr"/>
+          <a:lstStyle/>
+          <a:p>
+            <a:pPr algn="ctr" indent="0" marL="0">
+              <a:buNone/>
+            </a:pPr>
+            <a:r>
+              <a:rPr lang="en-US" sz="1200" b="1" dirty="0">
+                <a:solidFill>
+                  <a:schemeClr val="bg1"/>
+                </a:solidFill>
+              </a:rPr>
+              <a:t>Right clock</a:t>
+            </a:r>
+            <a:endParaRPr lang="en-US" sz="1200" dirty="0"/>
+          </a:p>
+        </p:txBody>
+      </p:sp>
+      <p:sp>
+        <p:nvSpPr>
+          <p:cNvPr id="17" name="Clock 2 text"/>
+          <p:cNvSpPr txBox="1"/>
+          <p:nvPr/>
+        </p:nvSpPr>
+        <p:spPr>
+          <a:xfrm>
+            <a:off x="1737360" y="5074920"/>
+            <a:ext cx="6172200" cy="1051560"/>
+          </a:xfrm>
+          <a:prstGeom prst="rect">
+            <a:avLst/>
+          </a:prstGeom>
+          <a:noFill/>
+          <a:ln/>
+        </p:spPr>
+        <p:txBody>
+          <a:bodyPr wrap="square" lIns="0" tIns="0" rIns="0" bIns="0" rtlCol="0" anchor="t"/>
+          <a:lstStyle/>
+          <a:p>
+            <a:pPr indent="0" marL="0">
+              <a:buNone/>
+            </a:pPr>
+            <a:r>
+              <a:rPr lang="en-US" sz="1500" dirty="0">
+                <a:solidFill>
+                  <a:schemeClr val="tx1"/>
+                </a:solidFill>
+              </a:rPr>
+              <a:t>The document's own business date, such as the dispatch date or order date. Anything older than 60 days and finished is eligible.</a:t>
+            </a:r>
+            <a:endParaRPr lang="en-US" sz="1500" dirty="0"/>
+          </a:p>
+        </p:txBody>
+      </p:sp>
+      <p:sp>
+        <p:nvSpPr>
+          <p:cNvPr id="18" name="Impact card"/>
+          <p:cNvSpPr/>
+          <p:nvPr/>
+        </p:nvSpPr>
+        <p:spPr>
+          <a:xfrm>
+            <a:off x="8412480" y="1965960"/>
+            <a:ext cx="3227832" cy="2057400"/>
+          </a:xfrm>
+          <a:prstGeom prst="roundRect">
+            <a:avLst>
+              <a:gd name="adj" fmla="val 4444"/>
+            </a:avLst>
+          </a:prstGeom>
+          <a:solidFill>
+            <a:schemeClr val="bg2"/>
+          </a:solidFill>
+          <a:ln/>
+        </p:spPr>
+      </p:sp>
+      <p:sp>
+        <p:nvSpPr>
+          <p:cNvPr id="19" name="Impact heading"/>
+          <p:cNvSpPr txBox="1"/>
+          <p:nvPr/>
+        </p:nvSpPr>
+        <p:spPr>
+          <a:xfrm>
+            <a:off x="8641080" y="2148840"/>
+            <a:ext cx="2834640" cy="365760"/>
+          </a:xfrm>
+          <a:prstGeom prst="rect">
+            <a:avLst/>
+          </a:prstGeom>
+          <a:noFill/>
+          <a:ln/>
+        </p:spPr>
+        <p:txBody>
+          <a:bodyPr wrap="square" lIns="0" tIns="0" rIns="0" bIns="0" rtlCol="0" anchor="t"/>
+          <a:lstStyle/>
+          <a:p>
+            <a:pPr indent="0" marL="0">
+              <a:buNone/>
+            </a:pPr>
+            <a:r>
+              <a:rPr lang="en-US" sz="1800" b="1" dirty="0">
+                <a:solidFill>
+                  <a:schemeClr val="accent1"/>
+                </a:solidFill>
+              </a:rPr>
+              <a:t>The effect</a:t>
+            </a:r>
+            <a:endParaRPr lang="en-US" sz="1800" dirty="0"/>
+          </a:p>
+        </p:txBody>
+      </p:sp>
+      <p:sp>
+        <p:nvSpPr>
+          <p:cNvPr id="20" name="Impact text"/>
+          <p:cNvSpPr txBox="1"/>
+          <p:nvPr/>
+        </p:nvSpPr>
+        <p:spPr>
+          <a:xfrm>
+            <a:off x="8641080" y="2606040"/>
+            <a:ext cx="2834640" cy="1325880"/>
+          </a:xfrm>
+          <a:prstGeom prst="rect">
+            <a:avLst/>
+          </a:prstGeom>
+          <a:noFill/>
+          <a:ln/>
+        </p:spPr>
+        <p:txBody>
+          <a:bodyPr wrap="square" lIns="0" tIns="0" rIns="0" bIns="0" rtlCol="0" anchor="t"/>
+          <a:lstStyle/>
+          <a:p>
+            <a:pPr indent="0" marL="0">
+              <a:buNone/>
+            </a:pPr>
+            <a:r>
+              <a:rPr lang="en-US" sz="1400" dirty="0">
+                <a:solidFill>
+                  <a:schemeClr val="tx1"/>
+                </a:solidFill>
+              </a:rPr>
+              <a:t>A large backlog of overdue documents stayed in Sanity, so the live count kept pressing on the quota.</a:t>
+            </a:r>
+            <a:endParaRPr lang="en-US" sz="1400" dirty="0"/>
+          </a:p>
+        </p:txBody>
+      </p:sp>
+      <p:sp>
+        <p:nvSpPr>
+          <p:cNvPr id="21" name="Status card"/>
+          <p:cNvSpPr/>
+          <p:nvPr/>
+        </p:nvSpPr>
+        <p:spPr>
+          <a:xfrm>
+            <a:off x="8412480" y="4206240"/>
+            <a:ext cx="3227832" cy="2057400"/>
+          </a:xfrm>
+          <a:prstGeom prst="roundRect">
+            <a:avLst>
+              <a:gd name="adj" fmla="val 4444"/>
+            </a:avLst>
+          </a:prstGeom>
+          <a:solidFill>
+            <a:schemeClr val="bg2"/>
+          </a:solidFill>
+          <a:ln/>
+        </p:spPr>
+      </p:sp>
+      <p:sp>
+        <p:nvSpPr>
+          <p:cNvPr id="22" name="Status heading"/>
           <p:cNvSpPr txBox="1"/>
           <p:nvPr/>
         </p:nvSpPr>
@@ -14836,7 +14801,7 @@
       </p:sp>
       <p:sp>
         <p:nvSpPr>
-          <p:cNvPr id="10" name="Status text"/>
+          <p:cNvPr id="23" name="Status text"/>
           <p:cNvSpPr txBox="1"/>
           <p:nvPr/>
         </p:nvSpPr>
@@ -14864,7 +14829,7 @@
                   <a:schemeClr val="tx1"/>
                 </a:solidFill>
               </a:rPr>
-              <a:t>Take a backup first: the next cleanup will try to delete about 11,900 documents in one pass.</a:t>
+              <a:t>Take a backup first: the next cleanup will try to delete a very large batch of documents in one pass.</a:t>
             </a:r>
             <a:endParaRPr lang="en-US" sz="1400" dirty="0"/>
           </a:p>
@@ -15310,7 +15275,7 @@
                   <a:schemeClr val="tx1"/>
                 </a:solidFill>
               </a:rPr>
-              <a:t>694 master records: 601 stock items, 34 users, 18 bins, 17 suppliers, 16 categories, 8 sites.</a:t>
+              <a:t>Master records: stock items, users, bins, suppliers, categories and sites.</a:t>
             </a:r>
             <a:endParaRPr lang="en-US" sz="1400" dirty="0"/>
           </a:p>
@@ -17899,7 +17864,7 @@
                             <a:schemeClr val="tx1"/>
                           </a:solidFill>
                         </a:rPr>
-                        <a:t>Sanity quota, blocked at about 31,059</a:t>
+                        <a:t>Sanity quota, already blocking production</a:t>
                       </a:r>
                       <a:endParaRPr lang="en-US" sz="1500" dirty="0"/>
                     </a:p>
@@ -19560,7 +19525,7 @@
                 <a:ea typeface="+mj-lt" pitchFamily="34" charset="-122"/>
                 <a:cs typeface="+mj-lt" pitchFamily="34" charset="-120"/>
               </a:rPr>
-              <a:t>24,784</a:t>
+              <a:t>24,800+</a:t>
             </a:r>
             <a:endParaRPr lang="en-US" sz="3000" dirty="0"/>
           </a:p>

</xml_diff>

<commit_message>
Docs: reference the 25,000-document Sanity limit in the MongoDB migration documents
- Migration plan: add the confirmed 25,000-document limit; the June export
  (~24,784) is ~99% of it.
- Word document and deck: state the 25,000 limit and replace "quota and tier
  unknown" with "price unconfirmed (limit confirmed at 25,000)"; no record
  counts reintroduced.
- analysis.md and accuracy plan: use the June count (~99%) instead of the
  March count (~50%) for headroom.

Co-Authored-By: Claude Sonnet 5.5 <noreply@anthropic.com>
Claude-Session: https://claude.ai/code/session_01KJtFxuEaUDPzkEMnDgLJHH
</commit_message>
<xml_diff>
--- a/quotes/2026-09-15-sanity-to-mongodb-migration/CaterFlow-MongoDB-Migration-Deck.pptx
+++ b/quotes/2026-09-15-sanity-to-mongodb-migration/CaterFlow-MongoDB-Migration-Deck.pptx
@@ -1829,7 +1829,7 @@
           <a:p>
             <a:r>
               <a:rPr lang="en-US" dirty="0"/>
-              <a:t>The decision in one page. Production was blocked by Sanity's document quota. The migration touches roughly 24,800+ documents, as the quote states, and is quoted as a fixed SZL 20,000 over 96 to 139 estimated hours. Hosting is not part of the quote. Timeline: the work is now full-time, so about 3 to 4 weeks of build at 40 hours a week (estimate; the quote assumed 4 to 6 months after hours), plus a rollback window. The quote's fixed fee is unchanged here; whether the discounted rate still applies to full-time work is a decision for G-Solutions².</a:t>
+              <a:t>The decision in one page. Production was blocked by Sanity's document quota (CaterFlow's plan limit is 25,000 documents). The migration touches roughly 24,800+ documents, as the quote states, and is quoted as a fixed SZL 20,000 over 96 to 139 estimated hours. Hosting is not part of the quote. Timeline: the work is now full-time, so about 3 to 4 weeks of build at 40 hours a week (estimate; the quote assumed 4 to 6 months after hours), plus a rollback window. The quote's fixed fee is unchanged here; whether the discounted rate still applies to full-time work is a decision for G-Solutions².</a:t>
             </a:r>
             <a:endParaRPr lang="en-US" dirty="0"/>
           </a:p>
@@ -3397,6 +3397,10 @@
           </a:solidFill>
           <a:ln/>
         </p:spPr>
+        <p:txBody>
+          <a:bodyPr/>
+          <a:p/>
+        </p:txBody>
       </p:sp>
       <p:pic>
         <p:nvPicPr>
@@ -3594,6 +3598,10 @@
           </a:solidFill>
           <a:ln/>
         </p:spPr>
+        <p:txBody>
+          <a:bodyPr/>
+          <a:p/>
+        </p:txBody>
       </p:sp>
       <p:sp>
         <p:nvSpPr>
@@ -3691,6 +3699,10 @@
           </a:solidFill>
           <a:ln/>
         </p:spPr>
+        <p:txBody>
+          <a:bodyPr/>
+          <a:p/>
+        </p:txBody>
       </p:sp>
       <p:sp>
         <p:nvSpPr>
@@ -3968,6 +3980,10 @@
           </a:solidFill>
           <a:ln/>
         </p:spPr>
+        <p:txBody>
+          <a:bodyPr/>
+          <a:p/>
+        </p:txBody>
       </p:sp>
       <p:sp>
         <p:nvSpPr>
@@ -3993,6 +4009,10 @@
             <a:prstDash val="solid"/>
           </a:ln>
         </p:spPr>
+        <p:txBody>
+          <a:bodyPr/>
+          <a:p/>
+        </p:txBody>
       </p:sp>
       <p:sp>
         <p:nvSpPr>
@@ -4159,6 +4179,10 @@
           </a:solidFill>
           <a:ln/>
         </p:spPr>
+        <p:txBody>
+          <a:bodyPr/>
+          <a:p/>
+        </p:txBody>
       </p:sp>
       <p:sp>
         <p:nvSpPr>
@@ -4256,6 +4280,10 @@
           </a:solidFill>
           <a:ln/>
         </p:spPr>
+        <p:txBody>
+          <a:bodyPr/>
+          <a:p/>
+        </p:txBody>
       </p:sp>
       <p:sp>
         <p:nvSpPr>
@@ -4353,6 +4381,10 @@
           </a:solidFill>
           <a:ln/>
         </p:spPr>
+        <p:txBody>
+          <a:bodyPr/>
+          <a:p/>
+        </p:txBody>
       </p:sp>
       <p:sp>
         <p:nvSpPr>
@@ -4450,6 +4482,10 @@
           </a:solidFill>
           <a:ln/>
         </p:spPr>
+        <p:txBody>
+          <a:bodyPr/>
+          <a:p/>
+        </p:txBody>
       </p:sp>
       <p:sp>
         <p:nvSpPr>
@@ -4691,6 +4727,10 @@
           </a:solidFill>
           <a:ln/>
         </p:spPr>
+        <p:txBody>
+          <a:bodyPr/>
+          <a:p/>
+        </p:txBody>
       </p:sp>
       <p:sp>
         <p:nvSpPr>
@@ -4788,6 +4828,10 @@
           </a:solidFill>
           <a:ln/>
         </p:spPr>
+        <p:txBody>
+          <a:bodyPr/>
+          <a:p/>
+        </p:txBody>
       </p:sp>
       <p:sp>
         <p:nvSpPr>
@@ -4885,6 +4929,10 @@
           </a:solidFill>
           <a:ln/>
         </p:spPr>
+        <p:txBody>
+          <a:bodyPr/>
+          <a:p/>
+        </p:txBody>
       </p:sp>
       <p:sp>
         <p:nvSpPr>
@@ -5018,6 +5066,10 @@
           </a:solidFill>
           <a:ln/>
         </p:spPr>
+        <p:txBody>
+          <a:bodyPr/>
+          <a:p/>
+        </p:txBody>
       </p:sp>
       <p:sp>
         <p:nvSpPr>
@@ -5038,6 +5090,10 @@
           </a:solidFill>
           <a:ln/>
         </p:spPr>
+        <p:txBody>
+          <a:bodyPr/>
+          <a:p/>
+        </p:txBody>
       </p:sp>
       <p:pic>
         <p:nvPicPr>
@@ -5156,6 +5212,10 @@
           </a:solidFill>
           <a:ln/>
         </p:spPr>
+        <p:txBody>
+          <a:bodyPr/>
+          <a:p/>
+        </p:txBody>
       </p:sp>
       <p:sp>
         <p:nvSpPr>
@@ -5176,6 +5236,10 @@
           </a:solidFill>
           <a:ln/>
         </p:spPr>
+        <p:txBody>
+          <a:bodyPr/>
+          <a:p/>
+        </p:txBody>
       </p:sp>
       <p:pic>
         <p:nvPicPr>
@@ -5294,6 +5358,10 @@
           </a:solidFill>
           <a:ln/>
         </p:spPr>
+        <p:txBody>
+          <a:bodyPr/>
+          <a:p/>
+        </p:txBody>
       </p:sp>
       <p:sp>
         <p:nvSpPr>
@@ -5314,6 +5382,10 @@
           </a:solidFill>
           <a:ln/>
         </p:spPr>
+        <p:txBody>
+          <a:bodyPr/>
+          <a:p/>
+        </p:txBody>
       </p:sp>
       <p:pic>
         <p:nvPicPr>
@@ -5432,6 +5504,10 @@
           </a:solidFill>
           <a:ln/>
         </p:spPr>
+        <p:txBody>
+          <a:bodyPr/>
+          <a:p/>
+        </p:txBody>
       </p:sp>
       <p:sp>
         <p:nvSpPr>
@@ -5452,6 +5528,10 @@
           </a:solidFill>
           <a:ln/>
         </p:spPr>
+        <p:txBody>
+          <a:bodyPr/>
+          <a:p/>
+        </p:txBody>
       </p:sp>
       <p:pic>
         <p:nvPicPr>
@@ -7462,6 +7542,10 @@
           </a:solidFill>
           <a:ln/>
         </p:spPr>
+        <p:txBody>
+          <a:bodyPr/>
+          <a:p/>
+        </p:txBody>
       </p:sp>
       <p:sp>
         <p:nvSpPr>
@@ -7522,6 +7606,10 @@
             <a:tailEnd type="triangle"/>
           </a:ln>
         </p:spPr>
+        <p:txBody>
+          <a:bodyPr/>
+          <a:p/>
+        </p:txBody>
       </p:sp>
       <p:sp>
         <p:nvSpPr>
@@ -7544,6 +7632,10 @@
           </a:solidFill>
           <a:ln/>
         </p:spPr>
+        <p:txBody>
+          <a:bodyPr/>
+          <a:p/>
+        </p:txBody>
       </p:sp>
       <p:sp>
         <p:nvSpPr>
@@ -7604,6 +7696,10 @@
             <a:tailEnd type="triangle"/>
           </a:ln>
         </p:spPr>
+        <p:txBody>
+          <a:bodyPr/>
+          <a:p/>
+        </p:txBody>
       </p:sp>
       <p:sp>
         <p:nvSpPr>
@@ -7626,6 +7722,10 @@
           </a:solidFill>
           <a:ln/>
         </p:spPr>
+        <p:txBody>
+          <a:bodyPr/>
+          <a:p/>
+        </p:txBody>
       </p:sp>
       <p:sp>
         <p:nvSpPr>
@@ -7684,6 +7784,10 @@
           </a:solidFill>
           <a:ln/>
         </p:spPr>
+        <p:txBody>
+          <a:bodyPr/>
+          <a:p/>
+        </p:txBody>
       </p:sp>
       <p:sp>
         <p:nvSpPr>
@@ -7704,6 +7808,10 @@
           </a:solidFill>
           <a:ln/>
         </p:spPr>
+        <p:txBody>
+          <a:bodyPr/>
+          <a:p/>
+        </p:txBody>
       </p:sp>
       <p:pic>
         <p:nvPicPr>
@@ -7750,6 +7858,10 @@
           </a:solidFill>
           <a:ln/>
         </p:spPr>
+        <p:txBody>
+          <a:bodyPr/>
+          <a:p/>
+        </p:txBody>
       </p:sp>
       <p:sp>
         <p:nvSpPr>
@@ -7880,6 +7992,10 @@
           </a:solidFill>
           <a:ln/>
         </p:spPr>
+        <p:txBody>
+          <a:bodyPr/>
+          <a:p/>
+        </p:txBody>
       </p:sp>
       <p:sp>
         <p:nvSpPr>
@@ -7900,6 +8016,10 @@
           </a:solidFill>
           <a:ln/>
         </p:spPr>
+        <p:txBody>
+          <a:bodyPr/>
+          <a:p/>
+        </p:txBody>
       </p:sp>
       <p:pic>
         <p:nvPicPr>
@@ -7946,6 +8066,10 @@
           </a:solidFill>
           <a:ln/>
         </p:spPr>
+        <p:txBody>
+          <a:bodyPr/>
+          <a:p/>
+        </p:txBody>
       </p:sp>
       <p:sp>
         <p:nvSpPr>
@@ -8076,6 +8200,10 @@
           </a:solidFill>
           <a:ln/>
         </p:spPr>
+        <p:txBody>
+          <a:bodyPr/>
+          <a:p/>
+        </p:txBody>
       </p:sp>
       <p:sp>
         <p:nvSpPr>
@@ -8096,6 +8224,10 @@
           </a:solidFill>
           <a:ln/>
         </p:spPr>
+        <p:txBody>
+          <a:bodyPr/>
+          <a:p/>
+        </p:txBody>
       </p:sp>
       <p:pic>
         <p:nvPicPr>
@@ -8142,6 +8274,10 @@
           </a:solidFill>
           <a:ln/>
         </p:spPr>
+        <p:txBody>
+          <a:bodyPr/>
+          <a:p/>
+        </p:txBody>
       </p:sp>
       <p:sp>
         <p:nvSpPr>
@@ -8414,6 +8550,10 @@
           </a:solidFill>
           <a:ln/>
         </p:spPr>
+        <p:txBody>
+          <a:bodyPr/>
+          <a:p/>
+        </p:txBody>
       </p:sp>
       <p:pic>
         <p:nvPicPr>
@@ -8530,6 +8670,10 @@
           </a:solidFill>
           <a:ln/>
         </p:spPr>
+        <p:txBody>
+          <a:bodyPr/>
+          <a:p/>
+        </p:txBody>
       </p:sp>
       <p:pic>
         <p:nvPicPr>
@@ -8646,6 +8790,10 @@
           </a:solidFill>
           <a:ln/>
         </p:spPr>
+        <p:txBody>
+          <a:bodyPr/>
+          <a:p/>
+        </p:txBody>
       </p:sp>
       <p:pic>
         <p:nvPicPr>
@@ -8762,6 +8910,10 @@
           </a:solidFill>
           <a:ln/>
         </p:spPr>
+        <p:txBody>
+          <a:bodyPr/>
+          <a:p/>
+        </p:txBody>
       </p:sp>
       <p:pic>
         <p:nvPicPr>
@@ -8878,6 +9030,10 @@
           </a:solidFill>
           <a:ln/>
         </p:spPr>
+        <p:txBody>
+          <a:bodyPr/>
+          <a:p/>
+        </p:txBody>
       </p:sp>
       <p:pic>
         <p:nvPicPr>
@@ -8994,6 +9150,10 @@
           </a:solidFill>
           <a:ln/>
         </p:spPr>
+        <p:txBody>
+          <a:bodyPr/>
+          <a:p/>
+        </p:txBody>
       </p:sp>
       <p:pic>
         <p:nvPicPr>
@@ -9256,6 +9416,10 @@
           </a:solidFill>
           <a:ln/>
         </p:spPr>
+        <p:txBody>
+          <a:bodyPr/>
+          <a:p/>
+        </p:txBody>
       </p:sp>
       <p:sp>
         <p:nvSpPr>
@@ -9276,6 +9440,10 @@
           </a:solidFill>
           <a:ln/>
         </p:spPr>
+        <p:txBody>
+          <a:bodyPr/>
+          <a:p/>
+        </p:txBody>
       </p:sp>
       <p:pic>
         <p:nvPicPr>
@@ -9358,6 +9526,10 @@
           </a:solidFill>
           <a:ln/>
         </p:spPr>
+        <p:txBody>
+          <a:bodyPr/>
+          <a:p/>
+        </p:txBody>
       </p:sp>
       <p:sp>
         <p:nvSpPr>
@@ -9378,6 +9550,10 @@
           </a:solidFill>
           <a:ln/>
         </p:spPr>
+        <p:txBody>
+          <a:bodyPr/>
+          <a:p/>
+        </p:txBody>
       </p:sp>
       <p:pic>
         <p:nvPicPr>
@@ -9460,6 +9636,10 @@
           </a:solidFill>
           <a:ln/>
         </p:spPr>
+        <p:txBody>
+          <a:bodyPr/>
+          <a:p/>
+        </p:txBody>
       </p:sp>
       <p:sp>
         <p:nvSpPr>
@@ -9480,6 +9660,10 @@
           </a:solidFill>
           <a:ln/>
         </p:spPr>
+        <p:txBody>
+          <a:bodyPr/>
+          <a:p/>
+        </p:txBody>
       </p:sp>
       <p:pic>
         <p:nvPicPr>
@@ -9562,6 +9746,10 @@
           </a:solidFill>
           <a:ln/>
         </p:spPr>
+        <p:txBody>
+          <a:bodyPr/>
+          <a:p/>
+        </p:txBody>
       </p:sp>
       <p:sp>
         <p:nvSpPr>
@@ -9582,6 +9770,10 @@
           </a:solidFill>
           <a:ln/>
         </p:spPr>
+        <p:txBody>
+          <a:bodyPr/>
+          <a:p/>
+        </p:txBody>
       </p:sp>
       <p:pic>
         <p:nvPicPr>
@@ -9664,6 +9856,10 @@
           </a:solidFill>
           <a:ln/>
         </p:spPr>
+        <p:txBody>
+          <a:bodyPr/>
+          <a:p/>
+        </p:txBody>
       </p:sp>
       <p:sp>
         <p:nvSpPr>
@@ -9684,6 +9880,10 @@
           </a:solidFill>
           <a:ln/>
         </p:spPr>
+        <p:txBody>
+          <a:bodyPr/>
+          <a:p/>
+        </p:txBody>
       </p:sp>
       <p:pic>
         <p:nvPicPr>
@@ -9766,6 +9966,10 @@
           </a:solidFill>
           <a:ln/>
         </p:spPr>
+        <p:txBody>
+          <a:bodyPr/>
+          <a:p/>
+        </p:txBody>
       </p:sp>
       <p:sp>
         <p:nvSpPr>
@@ -9786,6 +9990,10 @@
           </a:solidFill>
           <a:ln/>
         </p:spPr>
+        <p:txBody>
+          <a:bodyPr/>
+          <a:p/>
+        </p:txBody>
       </p:sp>
       <p:pic>
         <p:nvPicPr>
@@ -9868,6 +10076,10 @@
           </a:solidFill>
           <a:ln/>
         </p:spPr>
+        <p:txBody>
+          <a:bodyPr/>
+          <a:p/>
+        </p:txBody>
       </p:sp>
       <p:sp>
         <p:nvSpPr>
@@ -10536,7 +10748,7 @@
                             <a:schemeClr val="tx1"/>
                           </a:solidFill>
                         </a:rPr>
-                        <a:t>Quota and tier unknown</a:t>
+                        <a:t>Sanity price unconfirmed</a:t>
                       </a:r>
                       <a:endParaRPr lang="en-US" sz="1300" dirty="0"/>
                     </a:p>
@@ -10597,7 +10809,7 @@
                             <a:schemeClr val="tx1"/>
                           </a:solidFill>
                         </a:rPr>
-                        <a:t>The assumed document-limit tier was contradicted</a:t>
+                        <a:t>Limit confirmed at 25,000 documents; price not yet checked</a:t>
                       </a:r>
                       <a:endParaRPr lang="en-US" sz="1300" dirty="0"/>
                     </a:p>
@@ -10658,7 +10870,7 @@
                             <a:schemeClr val="tx1"/>
                           </a:solidFill>
                         </a:rPr>
-                        <a:t>Confirm plan, limit and price on the Sanity billing page</a:t>
+                        <a:t>Confirm plan price on the Sanity billing page; track the live count against 25,000</a:t>
                       </a:r>
                       <a:endParaRPr lang="en-US" sz="1300" dirty="0"/>
                     </a:p>
@@ -11651,6 +11863,10 @@
           </a:solidFill>
           <a:ln/>
         </p:spPr>
+        <p:txBody>
+          <a:bodyPr/>
+          <a:p/>
+        </p:txBody>
       </p:sp>
       <p:sp>
         <p:nvSpPr>
@@ -11671,6 +11887,10 @@
           </a:solidFill>
           <a:ln/>
         </p:spPr>
+        <p:txBody>
+          <a:bodyPr/>
+          <a:p/>
+        </p:txBody>
       </p:sp>
       <p:sp>
         <p:nvSpPr>
@@ -11749,7 +11969,7 @@
                   <a:schemeClr val="tx1"/>
                 </a:solidFill>
               </a:rPr>
-              <a:t>Back up, deploy the retention fix, run one archive and one delete pass, confirm the quota.</a:t>
+              <a:t>Back up, deploy the retention fix, run one archive and one delete pass, confirm the live count is under 25,000.</a:t>
             </a:r>
             <a:endParaRPr lang="en-US" sz="1400" dirty="0"/>
           </a:p>
@@ -11776,6 +11996,10 @@
           </a:solidFill>
           <a:ln/>
         </p:spPr>
+        <p:txBody>
+          <a:bodyPr/>
+          <a:p/>
+        </p:txBody>
       </p:sp>
       <p:sp>
         <p:nvSpPr>
@@ -11796,6 +12020,10 @@
           </a:solidFill>
           <a:ln/>
         </p:spPr>
+        <p:txBody>
+          <a:bodyPr/>
+          <a:p/>
+        </p:txBody>
       </p:sp>
       <p:sp>
         <p:nvSpPr>
@@ -11901,6 +12129,10 @@
           </a:solidFill>
           <a:ln/>
         </p:spPr>
+        <p:txBody>
+          <a:bodyPr/>
+          <a:p/>
+        </p:txBody>
       </p:sp>
       <p:sp>
         <p:nvSpPr>
@@ -11921,6 +12153,10 @@
           </a:solidFill>
           <a:ln/>
         </p:spPr>
+        <p:txBody>
+          <a:bodyPr/>
+          <a:p/>
+        </p:txBody>
       </p:sp>
       <p:sp>
         <p:nvSpPr>
@@ -12026,6 +12262,10 @@
           </a:solidFill>
           <a:ln/>
         </p:spPr>
+        <p:txBody>
+          <a:bodyPr/>
+          <a:p/>
+        </p:txBody>
       </p:sp>
       <p:sp>
         <p:nvSpPr>
@@ -12046,6 +12286,10 @@
           </a:solidFill>
           <a:ln/>
         </p:spPr>
+        <p:txBody>
+          <a:bodyPr/>
+          <a:p/>
+        </p:txBody>
       </p:sp>
       <p:sp>
         <p:nvSpPr>
@@ -12151,6 +12395,10 @@
           </a:solidFill>
           <a:ln/>
         </p:spPr>
+        <p:txBody>
+          <a:bodyPr/>
+          <a:p/>
+        </p:txBody>
       </p:sp>
       <p:sp>
         <p:nvSpPr>
@@ -12171,6 +12419,10 @@
           </a:solidFill>
           <a:ln/>
         </p:spPr>
+        <p:txBody>
+          <a:bodyPr/>
+          <a:p/>
+        </p:txBody>
       </p:sp>
       <p:sp>
         <p:nvSpPr>
@@ -12276,6 +12528,10 @@
           </a:solidFill>
           <a:ln/>
         </p:spPr>
+        <p:txBody>
+          <a:bodyPr/>
+          <a:p/>
+        </p:txBody>
       </p:sp>
       <p:sp>
         <p:nvSpPr>
@@ -12296,6 +12552,10 @@
           </a:solidFill>
           <a:ln/>
         </p:spPr>
+        <p:txBody>
+          <a:bodyPr/>
+          <a:p/>
+        </p:txBody>
       </p:sp>
       <p:sp>
         <p:nvSpPr>
@@ -12401,6 +12661,10 @@
           </a:solidFill>
           <a:ln/>
         </p:spPr>
+        <p:txBody>
+          <a:bodyPr/>
+          <a:p/>
+        </p:txBody>
       </p:sp>
       <p:sp>
         <p:nvSpPr>
@@ -12421,6 +12685,10 @@
           </a:solidFill>
           <a:ln/>
         </p:spPr>
+        <p:txBody>
+          <a:bodyPr/>
+          <a:p/>
+        </p:txBody>
       </p:sp>
       <p:sp>
         <p:nvSpPr>
@@ -12670,6 +12938,10 @@
           </a:solidFill>
           <a:ln/>
         </p:spPr>
+        <p:txBody>
+          <a:bodyPr/>
+          <a:p/>
+        </p:txBody>
       </p:sp>
       <p:sp>
         <p:nvSpPr>
@@ -12767,6 +13039,10 @@
           </a:solidFill>
           <a:ln/>
         </p:spPr>
+        <p:txBody>
+          <a:bodyPr/>
+          <a:p/>
+        </p:txBody>
       </p:sp>
       <p:sp>
         <p:nvSpPr>
@@ -12864,6 +13140,10 @@
           </a:solidFill>
           <a:ln/>
         </p:spPr>
+        <p:txBody>
+          <a:bodyPr/>
+          <a:p/>
+        </p:txBody>
       </p:sp>
       <p:sp>
         <p:nvSpPr>
@@ -12961,6 +13241,10 @@
           </a:solidFill>
           <a:ln/>
         </p:spPr>
+        <p:txBody>
+          <a:bodyPr/>
+          <a:p/>
+        </p:txBody>
       </p:sp>
       <p:sp>
         <p:nvSpPr>
@@ -13058,6 +13342,10 @@
           </a:solidFill>
           <a:ln/>
         </p:spPr>
+        <p:txBody>
+          <a:bodyPr/>
+          <a:p/>
+        </p:txBody>
       </p:sp>
       <p:sp>
         <p:nvSpPr>
@@ -13155,6 +13443,10 @@
           </a:solidFill>
           <a:ln/>
         </p:spPr>
+        <p:txBody>
+          <a:bodyPr/>
+          <a:p/>
+        </p:txBody>
       </p:sp>
       <p:sp>
         <p:nvSpPr>
@@ -13396,6 +13688,10 @@
           </a:solidFill>
           <a:ln/>
         </p:spPr>
+        <p:txBody>
+          <a:bodyPr/>
+          <a:p/>
+        </p:txBody>
       </p:sp>
       <p:sp>
         <p:nvSpPr>
@@ -13466,7 +13762,7 @@
                   <a:schemeClr val="tx1"/>
                 </a:solidFill>
               </a:rPr>
-              <a:t>production has already hit Sanity's document quota</a:t>
+              <a:t>production has already hit Sanity's 25,000-document quota</a:t>
             </a:r>
             <a:endParaRPr lang="en-US" sz="1400" dirty="0"/>
           </a:p>
@@ -13493,6 +13789,10 @@
           </a:solidFill>
           <a:ln/>
         </p:spPr>
+        <p:txBody>
+          <a:bodyPr/>
+          <a:p/>
+        </p:txBody>
       </p:sp>
       <p:sp>
         <p:nvSpPr>
@@ -13590,6 +13890,10 @@
           </a:solidFill>
           <a:ln/>
         </p:spPr>
+        <p:txBody>
+          <a:bodyPr/>
+          <a:p/>
+        </p:txBody>
       </p:sp>
       <p:sp>
         <p:nvSpPr>
@@ -13687,6 +13991,10 @@
           </a:solidFill>
           <a:ln/>
         </p:spPr>
+        <p:txBody>
+          <a:bodyPr/>
+          <a:p/>
+        </p:txBody>
       </p:sp>
       <p:sp>
         <p:nvSpPr>
@@ -13782,6 +14090,10 @@
           </a:solidFill>
           <a:ln/>
         </p:spPr>
+        <p:txBody>
+          <a:bodyPr/>
+          <a:p/>
+        </p:txBody>
       </p:sp>
       <p:pic>
         <p:nvPicPr>
@@ -13898,6 +14210,10 @@
           </a:solidFill>
           <a:ln/>
         </p:spPr>
+        <p:txBody>
+          <a:bodyPr/>
+          <a:p/>
+        </p:txBody>
       </p:sp>
       <p:pic>
         <p:nvPicPr>
@@ -14014,6 +14330,10 @@
           </a:solidFill>
           <a:ln/>
         </p:spPr>
+        <p:txBody>
+          <a:bodyPr/>
+          <a:p/>
+        </p:txBody>
       </p:sp>
       <p:pic>
         <p:nvPicPr>
@@ -14276,6 +14596,10 @@
           </a:solidFill>
           <a:ln/>
         </p:spPr>
+        <p:txBody>
+          <a:bodyPr/>
+          <a:p/>
+        </p:txBody>
       </p:sp>
       <p:sp>
         <p:nvSpPr>
@@ -14296,6 +14620,10 @@
           </a:solidFill>
           <a:ln/>
         </p:spPr>
+        <p:txBody>
+          <a:bodyPr/>
+          <a:p/>
+        </p:txBody>
       </p:sp>
       <p:pic>
         <p:nvPicPr>
@@ -14378,6 +14706,10 @@
           </a:solidFill>
           <a:ln/>
         </p:spPr>
+        <p:txBody>
+          <a:bodyPr/>
+          <a:p/>
+        </p:txBody>
       </p:sp>
       <p:sp>
         <p:nvSpPr>
@@ -14472,6 +14804,10 @@
           </a:solidFill>
           <a:ln/>
         </p:spPr>
+        <p:txBody>
+          <a:bodyPr/>
+          <a:p/>
+        </p:txBody>
       </p:sp>
       <p:sp>
         <p:nvSpPr>
@@ -14492,6 +14828,10 @@
           </a:solidFill>
           <a:ln/>
         </p:spPr>
+        <p:txBody>
+          <a:bodyPr/>
+          <a:p/>
+        </p:txBody>
       </p:sp>
       <p:pic>
         <p:nvPicPr>
@@ -14574,6 +14914,10 @@
           </a:solidFill>
           <a:ln/>
         </p:spPr>
+        <p:txBody>
+          <a:bodyPr/>
+          <a:p/>
+        </p:txBody>
       </p:sp>
       <p:sp>
         <p:nvSpPr>
@@ -14668,6 +15012,10 @@
           </a:solidFill>
           <a:ln/>
         </p:spPr>
+        <p:txBody>
+          <a:bodyPr/>
+          <a:p/>
+        </p:txBody>
       </p:sp>
       <p:sp>
         <p:nvSpPr>
@@ -14762,6 +15110,10 @@
           </a:solidFill>
           <a:ln/>
         </p:spPr>
+        <p:txBody>
+          <a:bodyPr/>
+          <a:p/>
+        </p:txBody>
       </p:sp>
       <p:sp>
         <p:nvSpPr>
@@ -15000,6 +15352,10 @@
           </a:solidFill>
           <a:ln/>
         </p:spPr>
+        <p:txBody>
+          <a:bodyPr/>
+          <a:p/>
+        </p:txBody>
       </p:sp>
       <p:sp>
         <p:nvSpPr>
@@ -15020,6 +15376,10 @@
           </a:solidFill>
           <a:ln/>
         </p:spPr>
+        <p:txBody>
+          <a:bodyPr/>
+          <a:p/>
+        </p:txBody>
       </p:sp>
       <p:pic>
         <p:nvPicPr>
@@ -15160,6 +15520,10 @@
           </a:solidFill>
           <a:ln/>
         </p:spPr>
+        <p:txBody>
+          <a:bodyPr/>
+          <a:p/>
+        </p:txBody>
       </p:sp>
       <p:sp>
         <p:nvSpPr>
@@ -15180,6 +15544,10 @@
           </a:solidFill>
           <a:ln/>
         </p:spPr>
+        <p:txBody>
+          <a:bodyPr/>
+          <a:p/>
+        </p:txBody>
       </p:sp>
       <p:pic>
         <p:nvPicPr>
@@ -15320,6 +15688,10 @@
           </a:solidFill>
           <a:ln/>
         </p:spPr>
+        <p:txBody>
+          <a:bodyPr/>
+          <a:p/>
+        </p:txBody>
       </p:sp>
       <p:sp>
         <p:nvSpPr>
@@ -15340,6 +15712,10 @@
           </a:solidFill>
           <a:ln/>
         </p:spPr>
+        <p:txBody>
+          <a:bodyPr/>
+          <a:p/>
+        </p:txBody>
       </p:sp>
       <p:pic>
         <p:nvPicPr>
@@ -15660,6 +16036,10 @@
           </a:solidFill>
           <a:ln/>
         </p:spPr>
+        <p:txBody>
+          <a:bodyPr/>
+          <a:p/>
+        </p:txBody>
       </p:sp>
       <p:sp>
         <p:nvSpPr>
@@ -15754,6 +16134,10 @@
           </a:solidFill>
           <a:ln/>
         </p:spPr>
+        <p:txBody>
+          <a:bodyPr/>
+          <a:p/>
+        </p:txBody>
       </p:sp>
       <p:sp>
         <p:nvSpPr>
@@ -15848,6 +16232,10 @@
           </a:solidFill>
           <a:ln/>
         </p:spPr>
+        <p:txBody>
+          <a:bodyPr/>
+          <a:p/>
+        </p:txBody>
       </p:sp>
       <p:sp>
         <p:nvSpPr>
@@ -15908,6 +16296,10 @@
             <a:tailEnd type="triangle"/>
           </a:ln>
         </p:spPr>
+        <p:txBody>
+          <a:bodyPr/>
+          <a:p/>
+        </p:txBody>
       </p:sp>
       <p:sp>
         <p:nvSpPr>
@@ -15932,6 +16324,10 @@
             <a:tailEnd type="triangle"/>
           </a:ln>
         </p:spPr>
+        <p:txBody>
+          <a:bodyPr/>
+          <a:p/>
+        </p:txBody>
       </p:sp>
       <p:sp>
         <p:nvSpPr>
@@ -15956,6 +16352,10 @@
             <a:tailEnd type="triangle"/>
           </a:ln>
         </p:spPr>
+        <p:txBody>
+          <a:bodyPr/>
+          <a:p/>
+        </p:txBody>
       </p:sp>
       <p:sp>
         <p:nvSpPr>
@@ -15978,6 +16378,10 @@
           </a:solidFill>
           <a:ln/>
         </p:spPr>
+        <p:txBody>
+          <a:bodyPr/>
+          <a:p/>
+        </p:txBody>
       </p:sp>
       <p:sp>
         <p:nvSpPr>
@@ -16072,6 +16476,10 @@
           </a:solidFill>
           <a:ln/>
         </p:spPr>
+        <p:txBody>
+          <a:bodyPr/>
+          <a:p/>
+        </p:txBody>
       </p:sp>
       <p:sp>
         <p:nvSpPr>
@@ -16166,6 +16574,10 @@
           </a:solidFill>
           <a:ln/>
         </p:spPr>
+        <p:txBody>
+          <a:bodyPr/>
+          <a:p/>
+        </p:txBody>
       </p:sp>
       <p:sp>
         <p:nvSpPr>
@@ -16440,6 +16852,10 @@
           </a:solidFill>
           <a:ln/>
         </p:spPr>
+        <p:txBody>
+          <a:bodyPr/>
+          <a:p/>
+        </p:txBody>
       </p:sp>
       <p:sp>
         <p:nvSpPr>
@@ -16460,6 +16876,10 @@
           </a:solidFill>
           <a:ln/>
         </p:spPr>
+        <p:txBody>
+          <a:bodyPr/>
+          <a:p/>
+        </p:txBody>
       </p:sp>
       <p:pic>
         <p:nvPicPr>
@@ -16578,6 +16998,10 @@
           </a:solidFill>
           <a:ln/>
         </p:spPr>
+        <p:txBody>
+          <a:bodyPr/>
+          <a:p/>
+        </p:txBody>
       </p:sp>
       <p:sp>
         <p:nvSpPr>
@@ -16598,6 +17022,10 @@
           </a:solidFill>
           <a:ln/>
         </p:spPr>
+        <p:txBody>
+          <a:bodyPr/>
+          <a:p/>
+        </p:txBody>
       </p:sp>
       <p:pic>
         <p:nvPicPr>
@@ -16716,6 +17144,10 @@
           </a:solidFill>
           <a:ln/>
         </p:spPr>
+        <p:txBody>
+          <a:bodyPr/>
+          <a:p/>
+        </p:txBody>
       </p:sp>
       <p:sp>
         <p:nvSpPr>
@@ -16736,6 +17168,10 @@
           </a:solidFill>
           <a:ln/>
         </p:spPr>
+        <p:txBody>
+          <a:bodyPr/>
+          <a:p/>
+        </p:txBody>
       </p:sp>
       <p:pic>
         <p:nvPicPr>
@@ -16854,6 +17290,10 @@
           </a:solidFill>
           <a:ln/>
         </p:spPr>
+        <p:txBody>
+          <a:bodyPr/>
+          <a:p/>
+        </p:txBody>
       </p:sp>
       <p:sp>
         <p:nvSpPr>
@@ -16874,6 +17314,10 @@
           </a:solidFill>
           <a:ln/>
         </p:spPr>
+        <p:txBody>
+          <a:bodyPr/>
+          <a:p/>
+        </p:txBody>
       </p:sp>
       <p:pic>
         <p:nvPicPr>
@@ -16992,6 +17436,10 @@
           </a:solidFill>
           <a:ln/>
         </p:spPr>
+        <p:txBody>
+          <a:bodyPr/>
+          <a:p/>
+        </p:txBody>
       </p:sp>
       <p:sp>
         <p:nvSpPr>
@@ -17012,6 +17460,10 @@
           </a:solidFill>
           <a:ln/>
         </p:spPr>
+        <p:txBody>
+          <a:bodyPr/>
+          <a:p/>
+        </p:txBody>
       </p:sp>
       <p:pic>
         <p:nvPicPr>
@@ -17130,6 +17582,10 @@
           </a:solidFill>
           <a:ln/>
         </p:spPr>
+        <p:txBody>
+          <a:bodyPr/>
+          <a:p/>
+        </p:txBody>
       </p:sp>
       <p:sp>
         <p:nvSpPr>
@@ -17150,6 +17606,10 @@
           </a:solidFill>
           <a:ln/>
         </p:spPr>
+        <p:txBody>
+          <a:bodyPr/>
+          <a:p/>
+        </p:txBody>
       </p:sp>
       <p:pic>
         <p:nvPicPr>
@@ -17864,7 +18324,7 @@
                             <a:schemeClr val="tx1"/>
                           </a:solidFill>
                         </a:rPr>
-                        <a:t>Sanity quota, already blocking production</a:t>
+                        <a:t>Sanity quota (25,000 documents), already blocking production</a:t>
                       </a:r>
                       <a:endParaRPr lang="en-US" sz="1500" dirty="0"/>
                     </a:p>
@@ -19103,6 +19563,10 @@
           </a:solidFill>
           <a:ln/>
         </p:spPr>
+        <p:txBody>
+          <a:bodyPr/>
+          <a:p/>
+        </p:txBody>
       </p:sp>
       <p:sp>
         <p:nvSpPr>
@@ -19200,6 +19664,10 @@
           </a:solidFill>
           <a:ln/>
         </p:spPr>
+        <p:txBody>
+          <a:bodyPr/>
+          <a:p/>
+        </p:txBody>
       </p:sp>
       <p:sp>
         <p:nvSpPr>
@@ -19297,6 +19765,10 @@
           </a:solidFill>
           <a:ln/>
         </p:spPr>
+        <p:txBody>
+          <a:bodyPr/>
+          <a:p/>
+        </p:txBody>
       </p:sp>
       <p:sp>
         <p:nvSpPr>
@@ -19394,6 +19866,10 @@
           </a:solidFill>
           <a:ln/>
         </p:spPr>
+        <p:txBody>
+          <a:bodyPr/>
+          <a:p/>
+        </p:txBody>
       </p:sp>
       <p:sp>
         <p:nvSpPr>
@@ -19491,6 +19967,10 @@
           </a:solidFill>
           <a:ln/>
         </p:spPr>
+        <p:txBody>
+          <a:bodyPr/>
+          <a:p/>
+        </p:txBody>
       </p:sp>
       <p:sp>
         <p:nvSpPr>
@@ -19586,6 +20066,10 @@
           </a:solidFill>
           <a:ln/>
         </p:spPr>
+        <p:txBody>
+          <a:bodyPr/>
+          <a:p/>
+        </p:txBody>
       </p:sp>
       <p:pic>
         <p:nvPicPr>
@@ -19702,6 +20186,10 @@
           </a:solidFill>
           <a:ln/>
         </p:spPr>
+        <p:txBody>
+          <a:bodyPr/>
+          <a:p/>
+        </p:txBody>
       </p:sp>
       <p:pic>
         <p:nvPicPr>
@@ -19818,6 +20306,10 @@
           </a:solidFill>
           <a:ln/>
         </p:spPr>
+        <p:txBody>
+          <a:bodyPr/>
+          <a:p/>
+        </p:txBody>
       </p:sp>
       <p:pic>
         <p:nvPicPr>
@@ -19934,6 +20426,10 @@
           </a:solidFill>
           <a:ln/>
         </p:spPr>
+        <p:txBody>
+          <a:bodyPr/>
+          <a:p/>
+        </p:txBody>
       </p:sp>
       <p:pic>
         <p:nvPicPr>
@@ -20196,6 +20692,10 @@
           </a:solidFill>
           <a:ln/>
         </p:spPr>
+        <p:txBody>
+          <a:bodyPr/>
+          <a:p/>
+        </p:txBody>
       </p:sp>
       <p:sp>
         <p:nvSpPr>
@@ -20216,6 +20716,10 @@
           </a:solidFill>
           <a:ln/>
         </p:spPr>
+        <p:txBody>
+          <a:bodyPr/>
+          <a:p/>
+        </p:txBody>
       </p:sp>
       <p:pic>
         <p:nvPicPr>
@@ -20457,6 +20961,10 @@
           </a:solidFill>
           <a:ln/>
         </p:spPr>
+        <p:txBody>
+          <a:bodyPr/>
+          <a:p/>
+        </p:txBody>
       </p:sp>
       <p:sp>
         <p:nvSpPr>
@@ -20515,6 +21023,10 @@
           </a:solidFill>
           <a:ln/>
         </p:spPr>
+        <p:txBody>
+          <a:bodyPr/>
+          <a:p/>
+        </p:txBody>
       </p:sp>
       <p:sp>
         <p:nvSpPr>
@@ -20535,6 +21047,10 @@
           </a:solidFill>
           <a:ln/>
         </p:spPr>
+        <p:txBody>
+          <a:bodyPr/>
+          <a:p/>
+        </p:txBody>
       </p:sp>
       <p:pic>
         <p:nvPicPr>
@@ -20776,6 +21292,10 @@
           </a:solidFill>
           <a:ln/>
         </p:spPr>
+        <p:txBody>
+          <a:bodyPr/>
+          <a:p/>
+        </p:txBody>
       </p:sp>
       <p:sp>
         <p:nvSpPr>
@@ -20834,6 +21354,10 @@
           </a:solidFill>
           <a:ln/>
         </p:spPr>
+        <p:txBody>
+          <a:bodyPr/>
+          <a:p/>
+        </p:txBody>
       </p:sp>
       <p:sp>
         <p:nvSpPr>
@@ -20854,6 +21378,10 @@
           </a:solidFill>
           <a:ln/>
         </p:spPr>
+        <p:txBody>
+          <a:bodyPr/>
+          <a:p/>
+        </p:txBody>
       </p:sp>
       <p:pic>
         <p:nvPicPr>
@@ -21095,6 +21623,10 @@
           </a:solidFill>
           <a:ln/>
         </p:spPr>
+        <p:txBody>
+          <a:bodyPr/>
+          <a:p/>
+        </p:txBody>
       </p:sp>
       <p:sp>
         <p:nvSpPr>
@@ -21153,6 +21685,10 @@
           </a:solidFill>
           <a:ln/>
         </p:spPr>
+        <p:txBody>
+          <a:bodyPr/>
+          <a:p/>
+        </p:txBody>
       </p:sp>
       <p:sp>
         <p:nvSpPr>
@@ -21173,6 +21709,10 @@
           </a:solidFill>
           <a:ln/>
         </p:spPr>
+        <p:txBody>
+          <a:bodyPr/>
+          <a:p/>
+        </p:txBody>
       </p:sp>
       <p:pic>
         <p:nvPicPr>
@@ -21414,6 +21954,10 @@
           </a:solidFill>
           <a:ln/>
         </p:spPr>
+        <p:txBody>
+          <a:bodyPr/>
+          <a:p/>
+        </p:txBody>
       </p:sp>
       <p:sp>
         <p:nvSpPr>

</xml_diff>